<commit_message>
Gauntlet R1 build: L2 What's in the Playlist — roles defined on the page, serve table on p1, fit-scale words, exemplars + what-ifs, through-line sentence, deck question slides hide answers, listing per D2
Co-Authored-By: Claude Fable 5.1 <noreply@anthropic.com>
Claude-Session: https://claude.ai/code/session_01VWaJFc84eoA3U4f2VjTKjw
</commit_message>
<xml_diff>
--- a/products/ai-training-data-crate/dist/What's in the Playlist - Slides.pptx
+++ b/products/ai-training-data-crate/dist/What's in the Playlist - Slides.pptx
@@ -513,7 +513,7 @@
           <a:p>
             <a:r>
               <a:rPr lang="en-US" dirty="0"/>
-              <a:t>Open on this slide while students settle. Worksheet: Playlist Check, one per student (pairs share one request line). Fully unplugged — no devices needed.</a:t>
+              <a:t>Open on this slide while students settle. Worksheet: Playlist Check, one per student — each student fills their OWN sheet. Fully unplugged — no devices needed.</a:t>
             </a:r>
             <a:endParaRPr lang="en-US" dirty="0"/>
           </a:p>
@@ -601,7 +601,7 @@
           <a:p>
             <a:r>
               <a:rPr lang="en-US" dirty="0"/>
-              <a:t>Land it: from what got collected and what didn't. "Did someone do this on purpose?" Usually not — teams collect the data that's easiest to get, and easy data leans toward whoever is already over-represented. No villain required. If asked "isn't AI creative, though?": it can mash up playlist patterns into new combos, but it can't mash up a genre it has never heard.</a:t>
+              <a:t>ANSWER (not on the slide): from what got collected — and what didn't (1 min). "Did someone do this on purpose?" Usually not — teams collect the data that's easiest to get, and easy data leans toward whoever is already over-represented. No villain required — which is why good AI teams audit their playlists before shipping. If asked "isn't AI creative, though?": it can mash up playlist patterns into new combos, but it can't mash up a genre it has never heard.</a:t>
             </a:r>
             <a:endParaRPr lang="en-US" dirty="0"/>
           </a:p>
@@ -689,7 +689,7 @@
           <a:p>
             <a:r>
               <a:rPr lang="en-US" dirty="0"/>
-              <a:t>Bottom of the worksheet. Collect; exemplars are in the Teacher Guide. #1 assesses ISTE 1.1.d (input → patterns → output). #2 assesses CSTA 2-IC-21 — look for WHO gets worse help, not just "needs more songs."</a:t>
+              <a:t>Bottom of worksheet p.2. Collect; exemplars are in the Teacher Guide p.2. KEY #1: PATTERNS — the AI studies its playlist, learns what usually goes with what, and predicts. Assesses ISTE 1.1.d. KEY #2: whoever filled its playlist used football examples, so football patterns are all it can serve; students whose interests never made the playlist get worse help. Assesses CSTA 2-IC-21 — look for WHO gets worse help, not just "needs more songs." KEY #3: any real gap in the student's own words that names a person or a request; not "more songs." Assesses SL.6.1 (building on a partner's idea).</a:t>
             </a:r>
             <a:endParaRPr lang="en-US" dirty="0"/>
           </a:p>
@@ -777,7 +777,7 @@
           <a:p>
             <a:r>
               <a:rPr lang="en-US" dirty="0"/>
-              <a:t>Close on this. Next in the unit: Hallucination Hunters — fact-checking what an AI hands you.</a:t>
+              <a:t>Close on this: the playlist is the middle of human → AI → human, and a gap in it is why the human at the end has to check. Next in the unit: Hallucination Hunters (Lesson 3, sold separately) — fact-checking what an AI hands you. This lesson stands on its own.</a:t>
             </a:r>
             <a:endParaRPr lang="en-US" dirty="0"/>
           </a:p>
@@ -953,7 +953,7 @@
           <a:p>
             <a:r>
               <a:rPr lang="en-US" dirty="0"/>
-              <a:t>Fish for it: the app is doing its job perfectly; the playlist is the problem. When a student says it, hand them the imaginary aux cord — they just said the thesis of the lesson. Bridge: "If you did the genie lesson: it granted what you SAID. Today: where its answers even come from. Everything an AI 'knows' comes from a playlist of examples — its training data. It can remix the playlist, but it can't serve what was never in it. Today you'll BE the app."</a:t>
+              <a:t>ANSWER (not on the slide): the app is doing its job perfectly — the PLAYLIST is the problem. Fish for it. When a student says it, hand them the imaginary aux cord — they just said the thesis of the lesson. What if nobody gets there? Ask: "If I handed AutoMix one slow song, could it play it?" Yes — so the app works. What's missing? Bridge: "If you did the genie lesson: it granted what you SAID. If you didn't, no problem — today stands alone. Today: where an AI's answers even come from. Everything an AI 'knows' comes from a playlist of examples — its training data. It can remix the playlist, but it can't serve what was never in it. Today you'll BE the app."</a:t>
             </a:r>
             <a:endParaRPr lang="en-US" dirty="0"/>
           </a:p>
@@ -1217,7 +1217,7 @@
           <a:p>
             <a:r>
               <a:rPr lang="en-US" dirty="0"/>
-              <a:t>Answer: golden retriever — its best guess from its patterns. Gap in, gap out. Then hand out the Playlist Check worksheet.</a:t>
+              <a:t>ANSWER (not on the slide): golden retriever — its best guess from its patterns. Gap in, gap out. What if a student says "husky"? "Has this AI ever seen one? It can only pick from the patterns it has." Transition: "Hand out Playlist Check; pairs up." Point to the grey box at the top of page 1: Partner A is the App, Partner B is the Request Line.</a:t>
             </a:r>
             <a:endParaRPr lang="en-US" dirty="0"/>
           </a:p>
@@ -1305,7 +1305,7 @@
           <a:p>
             <a:r>
               <a:rPr lang="en-US" dirty="0"/>
-              <a:t>End Serve with one live request from a neighboring pair. Enforce the discussion rule out loud in step 3: before you add your idea, say back your partner's and build on it. Tomás, Priya and Jordan are the built-in failures — zero Spanish, nothing slow, nothing quiet.</a:t>
+              <a:t>Setup: the 12 song cards ARE the app's training data — cut them apart or just point. Odd number? A trio: two Request Lines, one App, swap twice. Serve: work the six printed requests (Priya, Nia, Tomás, Keisha, Malik, Jordan); end with one live request from a neighboring pair. Can't agree on a Fit? Each writes their own mark — disagreement is data; save it for the debrief. Gap Report: enforce the rule out loud — before you add your idea, repeat your partner's, then add to it. A pair writes "needs more songs"? Ask WHO asked for something that wasn't there. Fix: push past "add one slow song" — Tomás still has nothing. KEY: Tomás, Keisha and Jordan are the built-in failures — zero Spanish, nothing slow, nothing quiet.</a:t>
             </a:r>
             <a:endParaRPr lang="en-US" dirty="0"/>
           </a:p>
@@ -1393,7 +1393,7 @@
           <a:p>
             <a:r>
               <a:rPr lang="en-US" dirty="0"/>
-              <a:t>Leave this up during Serve the Request Line. Circulate. Answer key is in the Teacher Guide — Keisha and Malik should be Nailed it; Nia Close-ish at best; Tomás, Priya and Jordan Can't do it.</a:t>
+              <a:t>Leave this up during Serve the Request Line. Circulate. Answer key is in the Teacher Guide p.1 — Priya and Malik should be Perfect fit; Nia Kind of fits at best (Cool Down is medium, still a party track); Tomás, Keisha and Jordan Nothing fits.</a:t>
             </a:r>
             <a:endParaRPr lang="en-US" dirty="0"/>
           </a:p>
@@ -1481,7 +1481,7 @@
           <a:p>
             <a:r>
               <a:rPr lang="en-US" dirty="0"/>
-              <a:t>Pairs call out one gap they found. Connect: "Your playlist failed Tomás and Priya. Real playlists fail real people the same way." Walk the three examples (Teacher Guide p.3). Handle with care: some students in the room are the people these gaps mishear. Keep the frame "the playlist failed them, and playlists can be fixed" — never "the tech doesn't like you."</a:t>
+              <a:t>3–4 pairs call out one gap they found (1 min). Connect: "Your playlist failed Tomás and Keisha. Real playlists fail real people the same way." Walk the three real playlists (Teacher Guide p.2, 3 min): voice assistants understand best the voices that filled their training audio; face-analysis tools have had higher error rates on darker skin when training photos leaned lighter (documented in 2018 research); a recommendation app's playlist is millions of people's viewing behaviour — your own history is the request. Handle with care: some students in the room are the people these gaps mishear. Keep the frame "the playlist failed them, and playlists can be fixed" — never "the tech doesn't like you."</a:t>
             </a:r>
             <a:endParaRPr lang="en-US" dirty="0"/>
           </a:p>
@@ -2214,7 +2214,7 @@
         <p:spPr>
           <a:xfrm>
             <a:off x="3204972" y="3977640"/>
-            <a:ext cx="1485900" cy="310896"/>
+            <a:ext cx="2418588" cy="310896"/>
           </a:xfrm>
           <a:prstGeom prst="roundRect">
             <a:avLst>
@@ -2241,7 +2241,7 @@
         <p:spPr>
           <a:xfrm>
             <a:off x="3204972" y="3977640"/>
-            <a:ext cx="1485900" cy="310896"/>
+            <a:ext cx="2418588" cy="310896"/>
           </a:xfrm>
           <a:prstGeom prst="rect">
             <a:avLst/>
@@ -2265,7 +2265,7 @@
                 <a:ea typeface="Arial" pitchFamily="34" charset="-122"/>
                 <a:cs typeface="Arial" pitchFamily="34" charset="-120"/>
               </a:rPr>
-              <a:t>Works unplugged</a:t>
+              <a:t>No prep · No devices needed</a:t>
             </a:r>
             <a:endParaRPr lang="en-US" sz="1000" dirty="0"/>
           </a:p>
@@ -2468,7 +2468,7 @@
         <p:spPr>
           <a:xfrm>
             <a:off x="1737360" y="1188720"/>
-            <a:ext cx="6903720" cy="1873377"/>
+            <a:ext cx="6903720" cy="3406140"/>
           </a:xfrm>
           <a:prstGeom prst="rect">
             <a:avLst/>
@@ -2495,45 +2495,6 @@
               <a:t>Nobody put bad songs in your playlist — so where did the bias come from?</a:t>
             </a:r>
             <a:endParaRPr lang="en-US" sz="3000" dirty="0"/>
-          </a:p>
-        </p:txBody>
-      </p:sp>
-      <p:sp>
-        <p:nvSpPr>
-          <p:cNvPr id="8" name="Text 5"/>
-          <p:cNvSpPr txBox="1"/>
-          <p:nvPr/>
-        </p:nvSpPr>
-        <p:spPr>
-          <a:xfrm>
-            <a:off x="1737360" y="3199257"/>
-            <a:ext cx="6903720" cy="1395603"/>
-          </a:xfrm>
-          <a:prstGeom prst="rect">
-            <a:avLst/>
-          </a:prstGeom>
-          <a:noFill/>
-          <a:ln/>
-        </p:spPr>
-        <p:txBody>
-          <a:bodyPr wrap="square" lIns="0" tIns="0" rIns="0" bIns="0" rtlCol="0" anchor="t"/>
-          <a:lstStyle/>
-          <a:p>
-            <a:pPr indent="0" marL="0">
-              <a:buNone/>
-            </a:pPr>
-            <a:r>
-              <a:rPr lang="en-US" sz="1600" dirty="0">
-                <a:solidFill>
-                  <a:srgbClr val="A9A9C4"/>
-                </a:solidFill>
-                <a:latin typeface="Arial" pitchFamily="34" charset="0"/>
-                <a:ea typeface="Arial" pitchFamily="34" charset="-122"/>
-                <a:cs typeface="Arial" pitchFamily="34" charset="-120"/>
-              </a:rPr>
-              <a:t>From what got collected — and what didn't.</a:t>
-            </a:r>
-            <a:endParaRPr lang="en-US" sz="1600" dirty="0"/>
           </a:p>
         </p:txBody>
       </p:sp>
@@ -2814,6 +2775,27 @@
             </a:r>
             <a:endParaRPr lang="en-US" sz="1800" dirty="0"/>
           </a:p>
+          <a:p>
+            <a:pPr marL="342900" indent="-342900">
+              <a:spcAft>
+                <a:spcPts val="800"/>
+              </a:spcAft>
+              <a:buSzPct val="100000"/>
+              <a:buChar char="■"/>
+            </a:pPr>
+            <a:r>
+              <a:rPr lang="en-US" sz="1800" dirty="0">
+                <a:solidFill>
+                  <a:srgbClr val="E8E8F5"/>
+                </a:solidFill>
+                <a:latin typeface="Arial" pitchFamily="34" charset="0"/>
+                <a:ea typeface="Arial" pitchFamily="34" charset="-122"/>
+                <a:cs typeface="Arial" pitchFamily="34" charset="-120"/>
+              </a:rPr>
+              <a:t>3.  One gap your partner spotted before you did — in your own words.</a:t>
+            </a:r>
+            <a:endParaRPr lang="en-US" sz="1800" dirty="0"/>
+          </a:p>
         </p:txBody>
       </p:sp>
     </p:spTree>
@@ -3023,7 +3005,7 @@
                 <a:ea typeface="Arial" pitchFamily="34" charset="-122"/>
                 <a:cs typeface="Arial" pitchFamily="34" charset="-120"/>
               </a:rPr>
-              <a:t>No magic in the machine. A gap in the playlist is a gap in the AI — and playlists can be fixed.</a:t>
+              <a:t>You → the AI's playlist → you. A human starts it, the AI does the middle, a human checks — and playlists can be fixed.</a:t>
             </a:r>
             <a:endParaRPr lang="en-US" sz="1600" dirty="0"/>
           </a:p>
@@ -3409,7 +3391,7 @@
                 <a:ea typeface="Arial" pitchFamily="34" charset="-122"/>
                 <a:cs typeface="Arial" pitchFamily="34" charset="-120"/>
               </a:rPr>
-              <a:t>"A song for grandma's birthday dinner?"  →  "Say less. 'VOLUME WAR.' Grandma loves bass drops, probably."</a:t>
+              <a:t>"A song for grandma's birthday dinner?"  →  "Got it. 'VOLUME WAR.' Grandma loves bass drops, probably."</a:t>
             </a:r>
             <a:endParaRPr lang="en-US" sz="1500" dirty="0"/>
           </a:p>
@@ -3678,7 +3660,7 @@
         <p:spPr>
           <a:xfrm>
             <a:off x="1737360" y="1188720"/>
-            <a:ext cx="6903720" cy="1873377"/>
+            <a:ext cx="6903720" cy="3406140"/>
           </a:xfrm>
           <a:prstGeom prst="rect">
             <a:avLst/>
@@ -3705,45 +3687,6 @@
               <a:t>Is AutoMix bad at picking songs — or is something else broken?</a:t>
             </a:r>
             <a:endParaRPr lang="en-US" sz="3000" dirty="0"/>
-          </a:p>
-        </p:txBody>
-      </p:sp>
-      <p:sp>
-        <p:nvSpPr>
-          <p:cNvPr id="8" name="Text 5"/>
-          <p:cNvSpPr txBox="1"/>
-          <p:nvPr/>
-        </p:nvSpPr>
-        <p:spPr>
-          <a:xfrm>
-            <a:off x="1737360" y="3199257"/>
-            <a:ext cx="6903720" cy="1395603"/>
-          </a:xfrm>
-          <a:prstGeom prst="rect">
-            <a:avLst/>
-          </a:prstGeom>
-          <a:noFill/>
-          <a:ln/>
-        </p:spPr>
-        <p:txBody>
-          <a:bodyPr wrap="square" lIns="0" tIns="0" rIns="0" bIns="0" rtlCol="0" anchor="t"/>
-          <a:lstStyle/>
-          <a:p>
-            <a:pPr indent="0" marL="0">
-              <a:buNone/>
-            </a:pPr>
-            <a:r>
-              <a:rPr lang="en-US" sz="1600" dirty="0">
-                <a:solidFill>
-                  <a:srgbClr val="A9A9C4"/>
-                </a:solidFill>
-                <a:latin typeface="Arial" pitchFamily="34" charset="0"/>
-                <a:ea typeface="Arial" pitchFamily="34" charset="-122"/>
-                <a:cs typeface="Arial" pitchFamily="34" charset="-120"/>
-              </a:rPr>
-              <a:t>The app is doing its job perfectly. The PLAYLIST is the problem.</a:t>
-            </a:r>
-            <a:endParaRPr lang="en-US" sz="1600" dirty="0"/>
           </a:p>
         </p:txBody>
       </p:sp>
@@ -4893,7 +4836,7 @@
         <p:spPr>
           <a:xfrm>
             <a:off x="1737360" y="1188720"/>
-            <a:ext cx="6903720" cy="1873377"/>
+            <a:ext cx="6903720" cy="3406140"/>
           </a:xfrm>
           <a:prstGeom prst="rect">
             <a:avLst/>
@@ -4909,7 +4852,7 @@
               <a:buNone/>
             </a:pPr>
             <a:r>
-              <a:rPr lang="en-US" sz="2900" b="1" dirty="0">
+              <a:rPr lang="en-US" sz="3000" b="1" dirty="0">
                 <a:solidFill>
                   <a:srgbClr val="FFFFFF"/>
                 </a:solidFill>
@@ -4919,46 +4862,7 @@
               </a:rPr>
               <a:t>A photo AI's playlist is almost all golden retrievers. A husky walks in — what's it going to call it?</a:t>
             </a:r>
-            <a:endParaRPr lang="en-US" sz="2900" dirty="0"/>
-          </a:p>
-        </p:txBody>
-      </p:sp>
-      <p:sp>
-        <p:nvSpPr>
-          <p:cNvPr id="8" name="Text 5"/>
-          <p:cNvSpPr txBox="1"/>
-          <p:nvPr/>
-        </p:nvSpPr>
-        <p:spPr>
-          <a:xfrm>
-            <a:off x="1737360" y="3199257"/>
-            <a:ext cx="6903720" cy="1395603"/>
-          </a:xfrm>
-          <a:prstGeom prst="rect">
-            <a:avLst/>
-          </a:prstGeom>
-          <a:noFill/>
-          <a:ln/>
-        </p:spPr>
-        <p:txBody>
-          <a:bodyPr wrap="square" lIns="0" tIns="0" rIns="0" bIns="0" rtlCol="0" anchor="t"/>
-          <a:lstStyle/>
-          <a:p>
-            <a:pPr indent="0" marL="0">
-              <a:buNone/>
-            </a:pPr>
-            <a:r>
-              <a:rPr lang="en-US" sz="1600" dirty="0">
-                <a:solidFill>
-                  <a:srgbClr val="A9A9C4"/>
-                </a:solidFill>
-                <a:latin typeface="Arial" pitchFamily="34" charset="0"/>
-                <a:ea typeface="Arial" pitchFamily="34" charset="-122"/>
-                <a:cs typeface="Arial" pitchFamily="34" charset="-120"/>
-              </a:rPr>
-              <a:t>Its best guess from its patterns. Gap in, gap out.</a:t>
-            </a:r>
-            <a:endParaRPr lang="en-US" sz="1600" dirty="0"/>
+            <a:endParaRPr lang="en-US" sz="3000" dirty="0"/>
           </a:p>
         </p:txBody>
       </p:sp>
@@ -5313,7 +5217,7 @@
                 <a:ea typeface="Arial" pitchFamily="34" charset="-122"/>
                 <a:cs typeface="Arial" pitchFamily="34" charset="-120"/>
               </a:rPr>
-              <a:t>Pairs. One partner is the App, one runs the Request Line. The 12 song cards ARE the app's training data — cut them apart or just point.</a:t>
+              <a:t>Pairs. Partner A = the App. Partner B = the Request Line. The 12 cards are your playlist.</a:t>
             </a:r>
             <a:endParaRPr lang="en-US" sz="1200" dirty="0"/>
           </a:p>
@@ -5455,7 +5359,7 @@
                 <a:ea typeface="Arial" pitchFamily="34" charset="-122"/>
                 <a:cs typeface="Arial" pitchFamily="34" charset="-120"/>
               </a:rPr>
-              <a:t>Work the six requests (Keisha, Nia, Tomás, Priya, Malik, Jordan). Swap roles after three. App picks the best card; both rate the fit.</a:t>
+              <a:t>Six requests. App names the card; both write it and tick one Fit box. Swap after #3.</a:t>
             </a:r>
             <a:endParaRPr lang="en-US" sz="1200" dirty="0"/>
           </a:p>
@@ -5597,7 +5501,7 @@
                 <a:ea typeface="Arial" pitchFamily="34" charset="-122"/>
                 <a:cs typeface="Arial" pitchFamily="34" charset="-120"/>
               </a:rPr>
-              <a:t>Who does the playlist serve really well? Who does it leave out — and what do they get served instead? Say back your partner's idea, then build.</a:t>
+              <a:t>Who does the playlist serve well? Who does it leave out? Repeat your partner, then add.</a:t>
             </a:r>
             <a:endParaRPr lang="en-US" sz="1200" dirty="0"/>
           </a:p>
@@ -5739,7 +5643,7 @@
                 <a:ea typeface="Arial" pitchFamily="34" charset="-122"/>
                 <a:cs typeface="Arial" pitchFamily="34" charset="-120"/>
               </a:rPr>
-              <a:t>Invent 3 new cards that fix the biggest gaps. Push past "add one slow song" — which requests still have nothing?</a:t>
+              <a:t>Invent new cards for the biggest gaps — at least 2. Which request still has nothing?</a:t>
             </a:r>
             <a:endParaRPr lang="en-US" sz="1200" dirty="0"/>
           </a:p>
@@ -5952,7 +5856,7 @@
                 <a:ea typeface="Arial" pitchFamily="34" charset="-122"/>
                 <a:cs typeface="Arial" pitchFamily="34" charset="-120"/>
               </a:rPr>
-              <a:t>Rule 2 — You never refuse. Serve the closest card you've got — a feed always serves you SOMETHING.</a:t>
+              <a:t>Rule 2 — You never say no. Serve the closest card you've got — a music app always gives you SOMETHING.</a:t>
             </a:r>
             <a:endParaRPr lang="en-US" sz="1800" dirty="0"/>
           </a:p>
@@ -5973,7 +5877,7 @@
                 <a:ea typeface="Arial" pitchFamily="34" charset="-122"/>
                 <a:cs typeface="Arial" pitchFamily="34" charset="-120"/>
               </a:rPr>
-              <a:t>Rule 3 — Rate every serve honestly. The ratings are the data.</a:t>
+              <a:t>Rule 3 — Tick the Fit box honestly, on your own sheet. The ticks are the data.</a:t>
             </a:r>
             <a:endParaRPr lang="en-US" sz="1800" dirty="0"/>
           </a:p>
@@ -5994,7 +5898,7 @@
                 <a:ea typeface="Arial" pitchFamily="34" charset="-122"/>
                 <a:cs typeface="Arial" pitchFamily="34" charset="-120"/>
               </a:rPr>
-              <a:t>Fit:  ✓ Nailed it   ·   ~ Close-ish   ·   ✗ Playlist can't do it</a:t>
+              <a:t>Fit boxes:  Perfect fit  ·  Kind of fits  ·  Nothing fits  — tick ONE per request.</a:t>
             </a:r>
             <a:endParaRPr lang="en-US" sz="1800" dirty="0"/>
           </a:p>
@@ -6314,7 +6218,58 @@
                 <a:ea typeface="Arial" pitchFamily="34" charset="-122"/>
                 <a:cs typeface="Arial" pitchFamily="34" charset="-120"/>
               </a:rPr>
-              <a:t>Failed Tomás — zero Spanish tracks. Failed Priya — medium is not slow. Failed Jordan — nothing quiet exists. Nobody put bad songs in. Those songs were just never there.</a:t>
+              <a:t>Failed Tomás — zero Spanish tracks.</a:t>
+            </a:r>
+            <a:endParaRPr lang="en-US" sz="1700" dirty="0"/>
+          </a:p>
+          <a:p>
+            <a:pPr indent="0" marL="0">
+              <a:buNone/>
+            </a:pPr>
+            <a:r>
+              <a:rPr lang="en-US" sz="1700" dirty="0">
+                <a:solidFill>
+                  <a:srgbClr val="FFFFFF"/>
+                </a:solidFill>
+                <a:latin typeface="Arial" pitchFamily="34" charset="0"/>
+                <a:ea typeface="Arial" pitchFamily="34" charset="-122"/>
+                <a:cs typeface="Arial" pitchFamily="34" charset="-120"/>
+              </a:rPr>
+              <a:t>Failed Keisha — medium is not slow.</a:t>
+            </a:r>
+            <a:endParaRPr lang="en-US" sz="1700" dirty="0"/>
+          </a:p>
+          <a:p>
+            <a:pPr indent="0" marL="0">
+              <a:buNone/>
+            </a:pPr>
+            <a:r>
+              <a:rPr lang="en-US" sz="1700" dirty="0">
+                <a:solidFill>
+                  <a:srgbClr val="FFFFFF"/>
+                </a:solidFill>
+                <a:latin typeface="Arial" pitchFamily="34" charset="0"/>
+                <a:ea typeface="Arial" pitchFamily="34" charset="-122"/>
+                <a:cs typeface="Arial" pitchFamily="34" charset="-120"/>
+              </a:rPr>
+              <a:t>Failed Jordan — nothing quiet exists.</a:t>
+            </a:r>
+            <a:endParaRPr lang="en-US" sz="1700" dirty="0"/>
+          </a:p>
+          <a:p>
+            <a:pPr indent="0" marL="0">
+              <a:buNone/>
+            </a:pPr>
+            <a:r>
+              <a:rPr lang="en-US" sz="1700" dirty="0">
+                <a:solidFill>
+                  <a:srgbClr val="FFFFFF"/>
+                </a:solidFill>
+                <a:latin typeface="Arial" pitchFamily="34" charset="0"/>
+                <a:ea typeface="Arial" pitchFamily="34" charset="-122"/>
+                <a:cs typeface="Arial" pitchFamily="34" charset="-120"/>
+              </a:rPr>
+              <a:t>Nobody put bad songs in. They were never there.</a:t>
             </a:r>
             <a:endParaRPr lang="en-US" sz="1700" dirty="0"/>
           </a:p>
@@ -6419,7 +6374,41 @@
                 <a:ea typeface="Arial" pitchFamily="34" charset="-122"/>
                 <a:cs typeface="Arial" pitchFamily="34" charset="-120"/>
               </a:rPr>
-              <a:t>Voice assistants mishear less-common accents and kids' voices. Photo tools worked worse on darker skin when training photos leaned lighter. Your feed: one-genre history, one-genre feed.</a:t>
+              <a:t>Voice assistants mishear less-common accents and kids.</a:t>
+            </a:r>
+            <a:endParaRPr lang="en-US" sz="1700" dirty="0"/>
+          </a:p>
+          <a:p>
+            <a:pPr indent="0" marL="0">
+              <a:buNone/>
+            </a:pPr>
+            <a:r>
+              <a:rPr lang="en-US" sz="1700" dirty="0">
+                <a:solidFill>
+                  <a:srgbClr val="FFFFFF"/>
+                </a:solidFill>
+                <a:latin typeface="Arial" pitchFamily="34" charset="0"/>
+                <a:ea typeface="Arial" pitchFamily="34" charset="-122"/>
+                <a:cs typeface="Arial" pitchFamily="34" charset="-120"/>
+              </a:rPr>
+              <a:t>Photo tools: more errors on darker skin when photos ran lighter.</a:t>
+            </a:r>
+            <a:endParaRPr lang="en-US" sz="1700" dirty="0"/>
+          </a:p>
+          <a:p>
+            <a:pPr indent="0" marL="0">
+              <a:buNone/>
+            </a:pPr>
+            <a:r>
+              <a:rPr lang="en-US" sz="1700" dirty="0">
+                <a:solidFill>
+                  <a:srgbClr val="FFFFFF"/>
+                </a:solidFill>
+                <a:latin typeface="Arial" pitchFamily="34" charset="0"/>
+                <a:ea typeface="Arial" pitchFamily="34" charset="-122"/>
+                <a:cs typeface="Arial" pitchFamily="34" charset="-120"/>
+              </a:rPr>
+              <a:t>Your feed: it learned from millions of histories.</a:t>
             </a:r>
             <a:endParaRPr lang="en-US" sz="1700" dirty="0"/>
           </a:p>

</xml_diff>